<commit_message>
Add flagship demand estimate for the coming year
New page 3 sizes how many customers will buy an N or N-1 device in
202604 to 202704. Because the 202604 N generation did not exist a year
earlier, every N holder is a buyer, which anchors the observed year at
1.14M purchases and exposes the inflow term.

Only 601.8K of the 1.55M current flagship pool traces back through the
five transition states, so 943.5K arrived from outside - a 4.68%
acquisition rate on the non-flagship base. Applying that plus the
observed upgrade rates gives ~1.16M buyers, 708.5K on N and 455.8K on
N-1, with roughly 80% coming from outside today's flagship base.

Includes a risk-band split (76.6% Low or Mid) and a 1.04M to 1.30M
sensitivity range.

Co-Authored-By: Claude Opus 5 <noreply@anthropic.com>
Claude-Session: https://claude.ai/code/session_01VKpfo226Go9vQJYa4eoC1d
</commit_message>
<xml_diff>
--- a/AIS_Mobile_Summary.pptx
+++ b/AIS_Mobile_Summary.pptx
@@ -7,9 +7,10 @@
   <p:sldIdLst>
     <p:sldId id="256" r:id="rId2"/>
     <p:sldId id="257" r:id="rId3"/>
+    <p:sldId id="258" r:id="rId4"/>
   </p:sldIdLst>
   <p:notesMasterIdLst>
-    <p:notesMasterId r:id="rId4"/>
+    <p:notesMasterId r:id="rId5"/>
   </p:notesMasterIdLst>
   <p:sldSz cx="12192000" cy="6858000"/>
   <p:notesSz cx="6858000" cy="12192000"/>
@@ -615,6 +616,94 @@
             <a:fld id="{F7021451-1387-4CA6-816F-3879F97B5CBC}" type="slidenum">
               <a:rPr lang="en-US"/>
               <a:t>2</a:t>
+            </a:fld>
+            <a:endParaRPr lang="en-US"/>
+          </a:p>
+        </p:txBody>
+      </p:sp>
+    </p:spTree>
+    <p:extLst>
+      <p:ext uri="{BB962C8B-B14F-4D97-AF65-F5344CB8AC3E}">
+        <p14:creationId xmlns:p14="http://schemas.microsoft.com/office/powerpoint/2010/main" val="1024086991"/>
+      </p:ext>
+    </p:extLst>
+  </p:cSld>
+  <p:clrMapOvr>
+    <a:masterClrMapping/>
+  </p:clrMapOvr>
+</p:notes>
+</file>
+
+<file path=ppt/notesSlides/notesSlide3.xml><?xml version="1.0" encoding="utf-8"?>
+<p:notes xmlns:a="http://schemas.openxmlformats.org/drawingml/2006/main" xmlns:r="http://schemas.openxmlformats.org/officeDocument/2006/relationships" xmlns:p="http://schemas.openxmlformats.org/presentationml/2006/main">
+  <p:cSld>
+    <p:spTree>
+      <p:nvGrpSpPr>
+        <p:cNvPr id="1" name=""/>
+        <p:cNvGrpSpPr/>
+        <p:nvPr/>
+      </p:nvGrpSpPr>
+      <p:grpSpPr>
+        <a:xfrm>
+          <a:off x="0" y="0"/>
+          <a:ext cx="0" cy="0"/>
+          <a:chOff x="0" y="0"/>
+          <a:chExt cx="0" cy="0"/>
+        </a:xfrm>
+      </p:grpSpPr>
+      <p:sp>
+        <p:nvSpPr>
+          <p:cNvPr id="2" name="Slide Image Placeholder 1"/>
+          <p:cNvSpPr>
+            <a:spLocks noGrp="1" noRot="1" noChangeAspect="1"/>
+          </p:cNvSpPr>
+          <p:nvPr>
+            <p:ph type="sldImg"/>
+          </p:nvPr>
+        </p:nvSpPr>
+        <p:spPr/>
+      </p:sp>
+      <p:sp>
+        <p:nvSpPr>
+          <p:cNvPr id="3" name="Notes Placeholder 2"/>
+          <p:cNvSpPr>
+            <a:spLocks noGrp="1"/>
+          </p:cNvSpPr>
+          <p:nvPr>
+            <p:ph type="body" idx="1"/>
+          </p:nvPr>
+        </p:nvSpPr>
+        <p:spPr/>
+        <p:txBody>
+          <a:bodyPr/>
+          <a:lstStyle/>
+          <a:p>
+            <a:r>
+              <a:rPr lang="en-US" dirty="0"/>
+              <a:t>Method. The 202604 N generation did not exist at 202504, so all 678,687 N holders bought within the year; N-1 buyers are the 42,756 who moved N-1 to N-1 plus 414,589 who acquired it from outside the flagship base. That gives 1,136,032 purchases observed in the year. Only 943,465 of the 202604 flagship pool is traceable through the five transition states, so 943,465 arrived from outside - an acquisition rate of 4.68% on the 20,141,683 non-flagship base. Forecast applies those rates to the 202604 position. Caveats: one year of transitions only, no seasonality, and the estimate assumes a comparable flagship launch in the coming year. The inflow term carries about 80% of the volume, so the estimate is far more sensitive to the acquisition rate than to the upgrade rate.</a:t>
+            </a:r>
+            <a:endParaRPr lang="en-US" dirty="0"/>
+          </a:p>
+        </p:txBody>
+      </p:sp>
+      <p:sp>
+        <p:nvSpPr>
+          <p:cNvPr id="4" name="Slide Number Placeholder 3"/>
+          <p:cNvSpPr>
+            <a:spLocks noGrp="1"/>
+          </p:cNvSpPr>
+          <p:nvPr>
+            <p:ph type="sldNum" sz="quarter" idx="10"/>
+          </p:nvPr>
+        </p:nvSpPr>
+        <p:spPr/>
+        <p:txBody>
+          <a:bodyPr/>
+          <a:lstStyle/>
+          <a:p>
+            <a:fld id="{F7021451-1387-4CA6-816F-3879F97B5CBC}" type="slidenum">
+              <a:rPr lang="en-US"/>
+              <a:t>3</a:t>
             </a:fld>
             <a:endParaRPr lang="en-US"/>
           </a:p>
@@ -5406,6 +5495,2267 @@
 </p:sld>
 </file>
 
+<file path=ppt/slides/slide3.xml><?xml version="1.0" encoding="utf-8"?>
+<p:sld xmlns:a="http://schemas.openxmlformats.org/drawingml/2006/main" xmlns:r="http://schemas.openxmlformats.org/officeDocument/2006/relationships" xmlns:p="http://schemas.openxmlformats.org/presentationml/2006/main">
+  <p:cSld name="Slide 3">
+    <p:bg>
+      <p:bgPr>
+        <a:solidFill>
+          <a:srgbClr val="FFFFFF"/>
+        </a:solidFill>
+      </p:bgPr>
+    </p:bg>
+    <p:spTree>
+      <p:nvGrpSpPr>
+        <p:cNvPr id="1" name=""/>
+        <p:cNvGrpSpPr/>
+        <p:nvPr/>
+      </p:nvGrpSpPr>
+      <p:grpSpPr>
+        <a:xfrm>
+          <a:off x="0" y="0"/>
+          <a:ext cx="0" cy="0"/>
+          <a:chOff x="0" y="0"/>
+          <a:chExt cx="0" cy="0"/>
+        </a:xfrm>
+      </p:grpSpPr>
+      <p:sp>
+        <p:nvSpPr>
+          <p:cNvPr id="2" name="Text 0"/>
+          <p:cNvSpPr/>
+          <p:nvPr/>
+        </p:nvSpPr>
+        <p:spPr>
+          <a:xfrm>
+            <a:off x="530352" y="283464"/>
+            <a:ext cx="11274552" cy="384048"/>
+          </a:xfrm>
+          <a:prstGeom prst="rect">
+            <a:avLst/>
+          </a:prstGeom>
+          <a:noFill/>
+          <a:ln/>
+        </p:spPr>
+        <p:txBody>
+          <a:bodyPr wrap="square" lIns="0" tIns="0" rIns="0" bIns="0" rtlCol="0" anchor="ctr"/>
+          <a:lstStyle/>
+          <a:p>
+            <a:pPr indent="0" marL="0">
+              <a:buNone/>
+            </a:pPr>
+            <a:r>
+              <a:rPr lang="en-US" sz="2200" b="1" dirty="0">
+                <a:solidFill>
+                  <a:srgbClr val="045D66"/>
+                </a:solidFill>
+                <a:latin typeface="Graphik TH" pitchFamily="34" charset="0"/>
+                <a:ea typeface="Graphik TH" pitchFamily="34" charset="-122"/>
+                <a:cs typeface="Graphik TH" pitchFamily="34" charset="-120"/>
+              </a:rPr>
+              <a:t>AIS Mobile Flagship Demand : ~1.16M buyers in the coming year</a:t>
+            </a:r>
+            <a:endParaRPr lang="en-US" sz="2200" dirty="0"/>
+          </a:p>
+        </p:txBody>
+      </p:sp>
+      <p:sp>
+        <p:nvSpPr>
+          <p:cNvPr id="3" name="Text 1"/>
+          <p:cNvSpPr/>
+          <p:nvPr/>
+        </p:nvSpPr>
+        <p:spPr>
+          <a:xfrm>
+            <a:off x="530352" y="713232"/>
+            <a:ext cx="11274552" cy="237744"/>
+          </a:xfrm>
+          <a:prstGeom prst="rect">
+            <a:avLst/>
+          </a:prstGeom>
+          <a:noFill/>
+          <a:ln/>
+        </p:spPr>
+        <p:txBody>
+          <a:bodyPr wrap="square" lIns="0" tIns="0" rIns="0" bIns="0" rtlCol="0" anchor="ctr"/>
+          <a:lstStyle/>
+          <a:p>
+            <a:pPr indent="0" marL="0">
+              <a:buNone/>
+            </a:pPr>
+            <a:r>
+              <a:rPr lang="en-US" sz="1150" i="1" dirty="0">
+                <a:solidFill>
+                  <a:srgbClr val="6B6B6B"/>
+                </a:solidFill>
+                <a:latin typeface="Graphik TH" pitchFamily="34" charset="0"/>
+                <a:ea typeface="Graphik TH" pitchFamily="34" charset="-122"/>
+                <a:cs typeface="Graphik TH" pitchFamily="34" charset="-120"/>
+              </a:rPr>
+              <a:t>*For the coming year (202604 → 202704), modelled on the observed 202504 → 202604 transitions; assumes a comparable flagship launch.</a:t>
+            </a:r>
+            <a:endParaRPr lang="en-US" sz="1150" dirty="0"/>
+          </a:p>
+        </p:txBody>
+      </p:sp>
+      <p:sp>
+        <p:nvSpPr>
+          <p:cNvPr id="4" name="Text 2"/>
+          <p:cNvSpPr/>
+          <p:nvPr/>
+        </p:nvSpPr>
+        <p:spPr>
+          <a:xfrm>
+            <a:off x="548640" y="1024128"/>
+            <a:ext cx="11064240" cy="237744"/>
+          </a:xfrm>
+          <a:prstGeom prst="rect">
+            <a:avLst/>
+          </a:prstGeom>
+          <a:noFill/>
+          <a:ln/>
+        </p:spPr>
+        <p:txBody>
+          <a:bodyPr wrap="square" lIns="0" tIns="0" rIns="0" bIns="0" rtlCol="0" anchor="ctr"/>
+          <a:lstStyle/>
+          <a:p>
+            <a:pPr indent="0" marL="0">
+              <a:buNone/>
+            </a:pPr>
+            <a:r>
+              <a:rPr lang="en-US" sz="1300" b="1" dirty="0">
+                <a:solidFill>
+                  <a:srgbClr val="045D66"/>
+                </a:solidFill>
+                <a:latin typeface="Graphik TH" pitchFamily="34" charset="0"/>
+                <a:ea typeface="Graphik TH" pitchFamily="34" charset="-122"/>
+                <a:cs typeface="Graphik TH" pitchFamily="34" charset="-120"/>
+              </a:rPr>
+              <a:t>Bought in the past year 1.14M   ·   Estimated for the coming year 1.16M   ·   Range 1.04M – 1.30M</a:t>
+            </a:r>
+            <a:endParaRPr lang="en-US" sz="1300" dirty="0"/>
+          </a:p>
+        </p:txBody>
+      </p:sp>
+      <p:sp>
+        <p:nvSpPr>
+          <p:cNvPr id="5" name="Text 3"/>
+          <p:cNvSpPr/>
+          <p:nvPr/>
+        </p:nvSpPr>
+        <p:spPr>
+          <a:xfrm>
+            <a:off x="548640" y="1261872"/>
+            <a:ext cx="11064240" cy="274320"/>
+          </a:xfrm>
+          <a:prstGeom prst="rect">
+            <a:avLst/>
+          </a:prstGeom>
+          <a:noFill/>
+          <a:ln/>
+        </p:spPr>
+        <p:txBody>
+          <a:bodyPr wrap="square" lIns="0" tIns="0" rIns="0" bIns="0" rtlCol="0" anchor="ctr"/>
+          <a:lstStyle/>
+          <a:p>
+            <a:pPr indent="0" marL="0">
+              <a:buNone/>
+            </a:pPr>
+            <a:r>
+              <a:rPr lang="en-US" sz="1400" dirty="0">
+                <a:solidFill>
+                  <a:srgbClr val="16233D"/>
+                </a:solidFill>
+                <a:latin typeface="Graphik TH" pitchFamily="34" charset="0"/>
+                <a:ea typeface="Graphik TH" pitchFamily="34" charset="-122"/>
+                <a:cs typeface="Graphik TH" pitchFamily="34" charset="-120"/>
+              </a:rPr>
+              <a:t>Four in five buyers come from outside today's flagship base — demand is inflow-driven, not owners cycling.</a:t>
+            </a:r>
+            <a:endParaRPr lang="en-US" sz="1400" dirty="0"/>
+          </a:p>
+        </p:txBody>
+      </p:sp>
+      <p:sp>
+        <p:nvSpPr>
+          <p:cNvPr id="6" name="Shape 4"/>
+          <p:cNvSpPr/>
+          <p:nvPr/>
+        </p:nvSpPr>
+        <p:spPr>
+          <a:xfrm>
+            <a:off x="530352" y="1645920"/>
+            <a:ext cx="2615184" cy="987552"/>
+          </a:xfrm>
+          <a:prstGeom prst="roundRect">
+            <a:avLst>
+              <a:gd name="adj" fmla="val 8333"/>
+            </a:avLst>
+          </a:prstGeom>
+          <a:solidFill>
+            <a:srgbClr val="F1F4F9"/>
+          </a:solidFill>
+          <a:ln/>
+        </p:spPr>
+      </p:sp>
+      <p:sp>
+        <p:nvSpPr>
+          <p:cNvPr id="7" name="Text 5"/>
+          <p:cNvSpPr/>
+          <p:nvPr/>
+        </p:nvSpPr>
+        <p:spPr>
+          <a:xfrm>
+            <a:off x="749808" y="1719072"/>
+            <a:ext cx="2194560" cy="402336"/>
+          </a:xfrm>
+          <a:prstGeom prst="rect">
+            <a:avLst/>
+          </a:prstGeom>
+          <a:noFill/>
+          <a:ln/>
+        </p:spPr>
+        <p:txBody>
+          <a:bodyPr wrap="square" lIns="0" tIns="0" rIns="0" bIns="0" rtlCol="0" anchor="ctr"/>
+          <a:lstStyle/>
+          <a:p>
+            <a:pPr indent="0" marL="0">
+              <a:buNone/>
+            </a:pPr>
+            <a:r>
+              <a:rPr lang="en-US" sz="2500" b="1" dirty="0">
+                <a:solidFill>
+                  <a:srgbClr val="00A896"/>
+                </a:solidFill>
+                <a:latin typeface="Graphik TH" pitchFamily="34" charset="0"/>
+                <a:ea typeface="Graphik TH" pitchFamily="34" charset="-122"/>
+                <a:cs typeface="Graphik TH" pitchFamily="34" charset="-120"/>
+              </a:rPr>
+              <a:t>1.14M</a:t>
+            </a:r>
+            <a:endParaRPr lang="en-US" sz="2500" dirty="0"/>
+          </a:p>
+        </p:txBody>
+      </p:sp>
+      <p:sp>
+        <p:nvSpPr>
+          <p:cNvPr id="8" name="Text 6"/>
+          <p:cNvSpPr/>
+          <p:nvPr/>
+        </p:nvSpPr>
+        <p:spPr>
+          <a:xfrm>
+            <a:off x="749808" y="2121408"/>
+            <a:ext cx="2194560" cy="237744"/>
+          </a:xfrm>
+          <a:prstGeom prst="rect">
+            <a:avLst/>
+          </a:prstGeom>
+          <a:noFill/>
+          <a:ln/>
+        </p:spPr>
+        <p:txBody>
+          <a:bodyPr wrap="square" lIns="0" tIns="0" rIns="0" bIns="0" rtlCol="0" anchor="t"/>
+          <a:lstStyle/>
+          <a:p>
+            <a:pPr indent="0" marL="0">
+              <a:buNone/>
+            </a:pPr>
+            <a:r>
+              <a:rPr lang="en-US" sz="1150" b="1" dirty="0">
+                <a:solidFill>
+                  <a:srgbClr val="16233D"/>
+                </a:solidFill>
+                <a:latin typeface="Graphik TH" pitchFamily="34" charset="0"/>
+                <a:ea typeface="Graphik TH" pitchFamily="34" charset="-122"/>
+                <a:cs typeface="Graphik TH" pitchFamily="34" charset="-120"/>
+              </a:rPr>
+              <a:t>bought in the past year</a:t>
+            </a:r>
+            <a:endParaRPr lang="en-US" sz="1150" dirty="0"/>
+          </a:p>
+        </p:txBody>
+      </p:sp>
+      <p:sp>
+        <p:nvSpPr>
+          <p:cNvPr id="9" name="Text 7"/>
+          <p:cNvSpPr/>
+          <p:nvPr/>
+        </p:nvSpPr>
+        <p:spPr>
+          <a:xfrm>
+            <a:off x="749808" y="2350008"/>
+            <a:ext cx="2194560" cy="237744"/>
+          </a:xfrm>
+          <a:prstGeom prst="rect">
+            <a:avLst/>
+          </a:prstGeom>
+          <a:noFill/>
+          <a:ln/>
+        </p:spPr>
+        <p:txBody>
+          <a:bodyPr wrap="square" lIns="0" tIns="0" rIns="0" bIns="0" rtlCol="0" anchor="t"/>
+          <a:lstStyle/>
+          <a:p>
+            <a:pPr indent="0" marL="0">
+              <a:buNone/>
+            </a:pPr>
+            <a:r>
+              <a:rPr lang="en-US" sz="1000" dirty="0">
+                <a:solidFill>
+                  <a:srgbClr val="6B7A90"/>
+                </a:solidFill>
+                <a:latin typeface="Graphik TH" pitchFamily="34" charset="0"/>
+                <a:ea typeface="Graphik TH" pitchFamily="34" charset="-122"/>
+                <a:cs typeface="Graphik TH" pitchFamily="34" charset="-120"/>
+              </a:rPr>
+              <a:t>observed 202504 → 202604</a:t>
+            </a:r>
+            <a:endParaRPr lang="en-US" sz="1000" dirty="0"/>
+          </a:p>
+        </p:txBody>
+      </p:sp>
+      <p:sp>
+        <p:nvSpPr>
+          <p:cNvPr id="10" name="Shape 8"/>
+          <p:cNvSpPr/>
+          <p:nvPr/>
+        </p:nvSpPr>
+        <p:spPr>
+          <a:xfrm>
+            <a:off x="3374136" y="1645920"/>
+            <a:ext cx="2615184" cy="987552"/>
+          </a:xfrm>
+          <a:prstGeom prst="roundRect">
+            <a:avLst>
+              <a:gd name="adj" fmla="val 8333"/>
+            </a:avLst>
+          </a:prstGeom>
+          <a:solidFill>
+            <a:srgbClr val="F1F4F9"/>
+          </a:solidFill>
+          <a:ln/>
+        </p:spPr>
+      </p:sp>
+      <p:sp>
+        <p:nvSpPr>
+          <p:cNvPr id="11" name="Text 9"/>
+          <p:cNvSpPr/>
+          <p:nvPr/>
+        </p:nvSpPr>
+        <p:spPr>
+          <a:xfrm>
+            <a:off x="3593592" y="1719072"/>
+            <a:ext cx="2194560" cy="402336"/>
+          </a:xfrm>
+          <a:prstGeom prst="rect">
+            <a:avLst/>
+          </a:prstGeom>
+          <a:noFill/>
+          <a:ln/>
+        </p:spPr>
+        <p:txBody>
+          <a:bodyPr wrap="square" lIns="0" tIns="0" rIns="0" bIns="0" rtlCol="0" anchor="ctr"/>
+          <a:lstStyle/>
+          <a:p>
+            <a:pPr indent="0" marL="0">
+              <a:buNone/>
+            </a:pPr>
+            <a:r>
+              <a:rPr lang="en-US" sz="2500" b="1" dirty="0">
+                <a:solidFill>
+                  <a:srgbClr val="00A896"/>
+                </a:solidFill>
+                <a:latin typeface="Graphik TH" pitchFamily="34" charset="0"/>
+                <a:ea typeface="Graphik TH" pitchFamily="34" charset="-122"/>
+                <a:cs typeface="Graphik TH" pitchFamily="34" charset="-120"/>
+              </a:rPr>
+              <a:t>1.16M</a:t>
+            </a:r>
+            <a:endParaRPr lang="en-US" sz="2500" dirty="0"/>
+          </a:p>
+        </p:txBody>
+      </p:sp>
+      <p:sp>
+        <p:nvSpPr>
+          <p:cNvPr id="12" name="Text 10"/>
+          <p:cNvSpPr/>
+          <p:nvPr/>
+        </p:nvSpPr>
+        <p:spPr>
+          <a:xfrm>
+            <a:off x="3593592" y="2121408"/>
+            <a:ext cx="2194560" cy="237744"/>
+          </a:xfrm>
+          <a:prstGeom prst="rect">
+            <a:avLst/>
+          </a:prstGeom>
+          <a:noFill/>
+          <a:ln/>
+        </p:spPr>
+        <p:txBody>
+          <a:bodyPr wrap="square" lIns="0" tIns="0" rIns="0" bIns="0" rtlCol="0" anchor="t"/>
+          <a:lstStyle/>
+          <a:p>
+            <a:pPr indent="0" marL="0">
+              <a:buNone/>
+            </a:pPr>
+            <a:r>
+              <a:rPr lang="en-US" sz="1150" b="1" dirty="0">
+                <a:solidFill>
+                  <a:srgbClr val="16233D"/>
+                </a:solidFill>
+                <a:latin typeface="Graphik TH" pitchFamily="34" charset="0"/>
+                <a:ea typeface="Graphik TH" pitchFamily="34" charset="-122"/>
+                <a:cs typeface="Graphik TH" pitchFamily="34" charset="-120"/>
+              </a:rPr>
+              <a:t>estimated, coming year</a:t>
+            </a:r>
+            <a:endParaRPr lang="en-US" sz="1150" dirty="0"/>
+          </a:p>
+        </p:txBody>
+      </p:sp>
+      <p:sp>
+        <p:nvSpPr>
+          <p:cNvPr id="13" name="Text 11"/>
+          <p:cNvSpPr/>
+          <p:nvPr/>
+        </p:nvSpPr>
+        <p:spPr>
+          <a:xfrm>
+            <a:off x="3593592" y="2350008"/>
+            <a:ext cx="2194560" cy="237744"/>
+          </a:xfrm>
+          <a:prstGeom prst="rect">
+            <a:avLst/>
+          </a:prstGeom>
+          <a:noFill/>
+          <a:ln/>
+        </p:spPr>
+        <p:txBody>
+          <a:bodyPr wrap="square" lIns="0" tIns="0" rIns="0" bIns="0" rtlCol="0" anchor="t"/>
+          <a:lstStyle/>
+          <a:p>
+            <a:pPr indent="0" marL="0">
+              <a:buNone/>
+            </a:pPr>
+            <a:r>
+              <a:rPr lang="en-US" sz="1000" dirty="0">
+                <a:solidFill>
+                  <a:srgbClr val="6B7A90"/>
+                </a:solidFill>
+                <a:latin typeface="Graphik TH" pitchFamily="34" charset="0"/>
+                <a:ea typeface="Graphik TH" pitchFamily="34" charset="-122"/>
+                <a:cs typeface="Graphik TH" pitchFamily="34" charset="-120"/>
+              </a:rPr>
+              <a:t>base case</a:t>
+            </a:r>
+            <a:endParaRPr lang="en-US" sz="1000" dirty="0"/>
+          </a:p>
+        </p:txBody>
+      </p:sp>
+      <p:sp>
+        <p:nvSpPr>
+          <p:cNvPr id="14" name="Shape 12"/>
+          <p:cNvSpPr/>
+          <p:nvPr/>
+        </p:nvSpPr>
+        <p:spPr>
+          <a:xfrm>
+            <a:off x="6217920" y="1645920"/>
+            <a:ext cx="2615184" cy="987552"/>
+          </a:xfrm>
+          <a:prstGeom prst="roundRect">
+            <a:avLst>
+              <a:gd name="adj" fmla="val 8333"/>
+            </a:avLst>
+          </a:prstGeom>
+          <a:solidFill>
+            <a:srgbClr val="F1F4F9"/>
+          </a:solidFill>
+          <a:ln/>
+        </p:spPr>
+      </p:sp>
+      <p:sp>
+        <p:nvSpPr>
+          <p:cNvPr id="15" name="Text 13"/>
+          <p:cNvSpPr/>
+          <p:nvPr/>
+        </p:nvSpPr>
+        <p:spPr>
+          <a:xfrm>
+            <a:off x="6437376" y="1719072"/>
+            <a:ext cx="2194560" cy="402336"/>
+          </a:xfrm>
+          <a:prstGeom prst="rect">
+            <a:avLst/>
+          </a:prstGeom>
+          <a:noFill/>
+          <a:ln/>
+        </p:spPr>
+        <p:txBody>
+          <a:bodyPr wrap="square" lIns="0" tIns="0" rIns="0" bIns="0" rtlCol="0" anchor="ctr"/>
+          <a:lstStyle/>
+          <a:p>
+            <a:pPr indent="0" marL="0">
+              <a:buNone/>
+            </a:pPr>
+            <a:r>
+              <a:rPr lang="en-US" sz="2500" b="1" dirty="0">
+                <a:solidFill>
+                  <a:srgbClr val="00A896"/>
+                </a:solidFill>
+                <a:latin typeface="Graphik TH" pitchFamily="34" charset="0"/>
+                <a:ea typeface="Graphik TH" pitchFamily="34" charset="-122"/>
+                <a:cs typeface="Graphik TH" pitchFamily="34" charset="-120"/>
+              </a:rPr>
+              <a:t>708.5K</a:t>
+            </a:r>
+            <a:endParaRPr lang="en-US" sz="2500" dirty="0"/>
+          </a:p>
+        </p:txBody>
+      </p:sp>
+      <p:sp>
+        <p:nvSpPr>
+          <p:cNvPr id="16" name="Text 14"/>
+          <p:cNvSpPr/>
+          <p:nvPr/>
+        </p:nvSpPr>
+        <p:spPr>
+          <a:xfrm>
+            <a:off x="6437376" y="2121408"/>
+            <a:ext cx="2194560" cy="237744"/>
+          </a:xfrm>
+          <a:prstGeom prst="rect">
+            <a:avLst/>
+          </a:prstGeom>
+          <a:noFill/>
+          <a:ln/>
+        </p:spPr>
+        <p:txBody>
+          <a:bodyPr wrap="square" lIns="0" tIns="0" rIns="0" bIns="0" rtlCol="0" anchor="t"/>
+          <a:lstStyle/>
+          <a:p>
+            <a:pPr indent="0" marL="0">
+              <a:buNone/>
+            </a:pPr>
+            <a:r>
+              <a:rPr lang="en-US" sz="1150" b="1" dirty="0">
+                <a:solidFill>
+                  <a:srgbClr val="16233D"/>
+                </a:solidFill>
+                <a:latin typeface="Graphik TH" pitchFamily="34" charset="0"/>
+                <a:ea typeface="Graphik TH" pitchFamily="34" charset="-122"/>
+                <a:cs typeface="Graphik TH" pitchFamily="34" charset="-120"/>
+              </a:rPr>
+              <a:t>expected to buy N</a:t>
+            </a:r>
+            <a:endParaRPr lang="en-US" sz="1150" dirty="0"/>
+          </a:p>
+        </p:txBody>
+      </p:sp>
+      <p:sp>
+        <p:nvSpPr>
+          <p:cNvPr id="17" name="Text 15"/>
+          <p:cNvSpPr/>
+          <p:nvPr/>
+        </p:nvSpPr>
+        <p:spPr>
+          <a:xfrm>
+            <a:off x="6437376" y="2350008"/>
+            <a:ext cx="2194560" cy="237744"/>
+          </a:xfrm>
+          <a:prstGeom prst="rect">
+            <a:avLst/>
+          </a:prstGeom>
+          <a:noFill/>
+          <a:ln/>
+        </p:spPr>
+        <p:txBody>
+          <a:bodyPr wrap="square" lIns="0" tIns="0" rIns="0" bIns="0" rtlCol="0" anchor="t"/>
+          <a:lstStyle/>
+          <a:p>
+            <a:pPr indent="0" marL="0">
+              <a:buNone/>
+            </a:pPr>
+            <a:r>
+              <a:rPr lang="en-US" sz="1000" dirty="0">
+                <a:solidFill>
+                  <a:srgbClr val="6B7A90"/>
+                </a:solidFill>
+                <a:latin typeface="Graphik TH" pitchFamily="34" charset="0"/>
+                <a:ea typeface="Graphik TH" pitchFamily="34" charset="-122"/>
+                <a:cs typeface="Graphik TH" pitchFamily="34" charset="-120"/>
+              </a:rPr>
+              <a:t>455.8K to buy N-1</a:t>
+            </a:r>
+            <a:endParaRPr lang="en-US" sz="1000" dirty="0"/>
+          </a:p>
+        </p:txBody>
+      </p:sp>
+      <p:sp>
+        <p:nvSpPr>
+          <p:cNvPr id="18" name="Shape 16"/>
+          <p:cNvSpPr/>
+          <p:nvPr/>
+        </p:nvSpPr>
+        <p:spPr>
+          <a:xfrm>
+            <a:off x="9061704" y="1645920"/>
+            <a:ext cx="2615184" cy="987552"/>
+          </a:xfrm>
+          <a:prstGeom prst="roundRect">
+            <a:avLst>
+              <a:gd name="adj" fmla="val 8333"/>
+            </a:avLst>
+          </a:prstGeom>
+          <a:solidFill>
+            <a:srgbClr val="F1F4F9"/>
+          </a:solidFill>
+          <a:ln/>
+        </p:spPr>
+      </p:sp>
+      <p:sp>
+        <p:nvSpPr>
+          <p:cNvPr id="19" name="Text 17"/>
+          <p:cNvSpPr/>
+          <p:nvPr/>
+        </p:nvSpPr>
+        <p:spPr>
+          <a:xfrm>
+            <a:off x="9281160" y="1719072"/>
+            <a:ext cx="2194560" cy="402336"/>
+          </a:xfrm>
+          <a:prstGeom prst="rect">
+            <a:avLst/>
+          </a:prstGeom>
+          <a:noFill/>
+          <a:ln/>
+        </p:spPr>
+        <p:txBody>
+          <a:bodyPr wrap="square" lIns="0" tIns="0" rIns="0" bIns="0" rtlCol="0" anchor="ctr"/>
+          <a:lstStyle/>
+          <a:p>
+            <a:pPr indent="0" marL="0">
+              <a:buNone/>
+            </a:pPr>
+            <a:r>
+              <a:rPr lang="en-US" sz="2500" b="1" dirty="0">
+                <a:solidFill>
+                  <a:srgbClr val="C00000"/>
+                </a:solidFill>
+                <a:latin typeface="Graphik TH" pitchFamily="34" charset="0"/>
+                <a:ea typeface="Graphik TH" pitchFamily="34" charset="-122"/>
+                <a:cs typeface="Graphik TH" pitchFamily="34" charset="-120"/>
+              </a:rPr>
+              <a:t>79.9%</a:t>
+            </a:r>
+            <a:endParaRPr lang="en-US" sz="2500" dirty="0"/>
+          </a:p>
+        </p:txBody>
+      </p:sp>
+      <p:sp>
+        <p:nvSpPr>
+          <p:cNvPr id="20" name="Text 18"/>
+          <p:cNvSpPr/>
+          <p:nvPr/>
+        </p:nvSpPr>
+        <p:spPr>
+          <a:xfrm>
+            <a:off x="9281160" y="2121408"/>
+            <a:ext cx="2194560" cy="237744"/>
+          </a:xfrm>
+          <a:prstGeom prst="rect">
+            <a:avLst/>
+          </a:prstGeom>
+          <a:noFill/>
+          <a:ln/>
+        </p:spPr>
+        <p:txBody>
+          <a:bodyPr wrap="square" lIns="0" tIns="0" rIns="0" bIns="0" rtlCol="0" anchor="t"/>
+          <a:lstStyle/>
+          <a:p>
+            <a:pPr indent="0" marL="0">
+              <a:buNone/>
+            </a:pPr>
+            <a:r>
+              <a:rPr lang="en-US" sz="1150" b="1" dirty="0">
+                <a:solidFill>
+                  <a:srgbClr val="16233D"/>
+                </a:solidFill>
+                <a:latin typeface="Graphik TH" pitchFamily="34" charset="0"/>
+                <a:ea typeface="Graphik TH" pitchFamily="34" charset="-122"/>
+                <a:cs typeface="Graphik TH" pitchFamily="34" charset="-120"/>
+              </a:rPr>
+              <a:t>from outside the base</a:t>
+            </a:r>
+            <a:endParaRPr lang="en-US" sz="1150" dirty="0"/>
+          </a:p>
+        </p:txBody>
+      </p:sp>
+      <p:sp>
+        <p:nvSpPr>
+          <p:cNvPr id="21" name="Text 19"/>
+          <p:cNvSpPr/>
+          <p:nvPr/>
+        </p:nvSpPr>
+        <p:spPr>
+          <a:xfrm>
+            <a:off x="9281160" y="2350008"/>
+            <a:ext cx="2194560" cy="237744"/>
+          </a:xfrm>
+          <a:prstGeom prst="rect">
+            <a:avLst/>
+          </a:prstGeom>
+          <a:noFill/>
+          <a:ln/>
+        </p:spPr>
+        <p:txBody>
+          <a:bodyPr wrap="square" lIns="0" tIns="0" rIns="0" bIns="0" rtlCol="0" anchor="t"/>
+          <a:lstStyle/>
+          <a:p>
+            <a:pPr indent="0" marL="0">
+              <a:buNone/>
+            </a:pPr>
+            <a:r>
+              <a:rPr lang="en-US" sz="1000" dirty="0">
+                <a:solidFill>
+                  <a:srgbClr val="6B7A90"/>
+                </a:solidFill>
+                <a:latin typeface="Graphik TH" pitchFamily="34" charset="0"/>
+                <a:ea typeface="Graphik TH" pitchFamily="34" charset="-122"/>
+                <a:cs typeface="Graphik TH" pitchFamily="34" charset="-120"/>
+              </a:rPr>
+              <a:t>930.6K of 1.16M</a:t>
+            </a:r>
+            <a:endParaRPr lang="en-US" sz="1000" dirty="0"/>
+          </a:p>
+        </p:txBody>
+      </p:sp>
+      <p:sp>
+        <p:nvSpPr>
+          <p:cNvPr id="22" name="Shape 20"/>
+          <p:cNvSpPr/>
+          <p:nvPr/>
+        </p:nvSpPr>
+        <p:spPr>
+          <a:xfrm>
+            <a:off x="530352" y="2761488"/>
+            <a:ext cx="4233672" cy="2743200"/>
+          </a:xfrm>
+          <a:prstGeom prst="roundRect">
+            <a:avLst>
+              <a:gd name="adj" fmla="val 3000"/>
+            </a:avLst>
+          </a:prstGeom>
+          <a:solidFill>
+            <a:srgbClr val="F1F4F9"/>
+          </a:solidFill>
+          <a:ln/>
+        </p:spPr>
+      </p:sp>
+      <p:sp>
+        <p:nvSpPr>
+          <p:cNvPr id="23" name="Text 21"/>
+          <p:cNvSpPr/>
+          <p:nvPr/>
+        </p:nvSpPr>
+        <p:spPr>
+          <a:xfrm>
+            <a:off x="749808" y="2907792"/>
+            <a:ext cx="3794760" cy="256032"/>
+          </a:xfrm>
+          <a:prstGeom prst="rect">
+            <a:avLst/>
+          </a:prstGeom>
+          <a:noFill/>
+          <a:ln/>
+        </p:spPr>
+        <p:txBody>
+          <a:bodyPr wrap="square" lIns="0" tIns="0" rIns="0" bIns="0" rtlCol="0" anchor="ctr"/>
+          <a:lstStyle/>
+          <a:p>
+            <a:pPr indent="0" marL="0">
+              <a:buNone/>
+            </a:pPr>
+            <a:r>
+              <a:rPr lang="en-US" sz="1300" b="1" dirty="0">
+                <a:solidFill>
+                  <a:srgbClr val="16233D"/>
+                </a:solidFill>
+                <a:latin typeface="Cambria" pitchFamily="34" charset="0"/>
+                <a:ea typeface="Cambria" pitchFamily="34" charset="-122"/>
+                <a:cs typeface="Cambria" pitchFamily="34" charset="-120"/>
+              </a:rPr>
+              <a:t>How the estimate builds</a:t>
+            </a:r>
+            <a:endParaRPr lang="en-US" sz="1300" dirty="0"/>
+          </a:p>
+        </p:txBody>
+      </p:sp>
+      <p:sp>
+        <p:nvSpPr>
+          <p:cNvPr id="24" name="Text 22"/>
+          <p:cNvSpPr/>
+          <p:nvPr/>
+        </p:nvSpPr>
+        <p:spPr>
+          <a:xfrm>
+            <a:off x="749808" y="3163824"/>
+            <a:ext cx="3794760" cy="219456"/>
+          </a:xfrm>
+          <a:prstGeom prst="rect">
+            <a:avLst/>
+          </a:prstGeom>
+          <a:noFill/>
+          <a:ln/>
+        </p:spPr>
+        <p:txBody>
+          <a:bodyPr wrap="square" lIns="0" tIns="0" rIns="0" bIns="0" rtlCol="0" anchor="ctr"/>
+          <a:lstStyle/>
+          <a:p>
+            <a:pPr indent="0" marL="0">
+              <a:buNone/>
+            </a:pPr>
+            <a:r>
+              <a:rPr lang="en-US" sz="950" dirty="0">
+                <a:solidFill>
+                  <a:srgbClr val="6B7A90"/>
+                </a:solidFill>
+                <a:latin typeface="Graphik TH" pitchFamily="34" charset="0"/>
+                <a:ea typeface="Graphik TH" pitchFamily="34" charset="-122"/>
+                <a:cs typeface="Graphik TH" pitchFamily="34" charset="-120"/>
+              </a:rPr>
+              <a:t>1.16M buyers, by source and device</a:t>
+            </a:r>
+            <a:endParaRPr lang="en-US" sz="950" dirty="0"/>
+          </a:p>
+        </p:txBody>
+      </p:sp>
+      <p:sp>
+        <p:nvSpPr>
+          <p:cNvPr id="25" name="Text 23"/>
+          <p:cNvSpPr/>
+          <p:nvPr/>
+        </p:nvSpPr>
+        <p:spPr>
+          <a:xfrm>
+            <a:off x="749808" y="3511296"/>
+            <a:ext cx="1325880" cy="274320"/>
+          </a:xfrm>
+          <a:prstGeom prst="rect">
+            <a:avLst/>
+          </a:prstGeom>
+          <a:noFill/>
+          <a:ln/>
+        </p:spPr>
+        <p:txBody>
+          <a:bodyPr wrap="square" lIns="0" tIns="0" rIns="0" bIns="0" rtlCol="0" anchor="ctr"/>
+          <a:lstStyle/>
+          <a:p>
+            <a:pPr indent="0" marL="0">
+              <a:buNone/>
+            </a:pPr>
+            <a:r>
+              <a:rPr lang="en-US" sz="1100" b="1" dirty="0">
+                <a:solidFill>
+                  <a:srgbClr val="16233D"/>
+                </a:solidFill>
+                <a:latin typeface="Graphik TH" pitchFamily="34" charset="0"/>
+                <a:ea typeface="Graphik TH" pitchFamily="34" charset="-122"/>
+                <a:cs typeface="Graphik TH" pitchFamily="34" charset="-120"/>
+              </a:rPr>
+              <a:t>Inflow → N</a:t>
+            </a:r>
+            <a:endParaRPr lang="en-US" sz="1100" dirty="0"/>
+          </a:p>
+        </p:txBody>
+      </p:sp>
+      <p:sp>
+        <p:nvSpPr>
+          <p:cNvPr id="26" name="Shape 24"/>
+          <p:cNvSpPr/>
+          <p:nvPr/>
+        </p:nvSpPr>
+        <p:spPr>
+          <a:xfrm>
+            <a:off x="2185416" y="3566160"/>
+            <a:ext cx="832104" cy="173736"/>
+          </a:xfrm>
+          <a:prstGeom prst="roundRect">
+            <a:avLst>
+              <a:gd name="adj" fmla="val 21053"/>
+            </a:avLst>
+          </a:prstGeom>
+          <a:solidFill>
+            <a:srgbClr val="165A73"/>
+          </a:solidFill>
+          <a:ln/>
+        </p:spPr>
+      </p:sp>
+      <p:sp>
+        <p:nvSpPr>
+          <p:cNvPr id="27" name="Text 25"/>
+          <p:cNvSpPr/>
+          <p:nvPr/>
+        </p:nvSpPr>
+        <p:spPr>
+          <a:xfrm>
+            <a:off x="3127248" y="3511296"/>
+            <a:ext cx="1417320" cy="274320"/>
+          </a:xfrm>
+          <a:prstGeom prst="rect">
+            <a:avLst/>
+          </a:prstGeom>
+          <a:noFill/>
+          <a:ln/>
+        </p:spPr>
+        <p:txBody>
+          <a:bodyPr wrap="square" lIns="0" tIns="0" rIns="0" bIns="0" rtlCol="0" anchor="ctr"/>
+          <a:lstStyle/>
+          <a:p>
+            <a:pPr algn="r" indent="0" marL="0">
+              <a:buNone/>
+            </a:pPr>
+            <a:r>
+              <a:rPr lang="en-US" sz="1100" b="1" dirty="0">
+                <a:solidFill>
+                  <a:srgbClr val="16233D"/>
+                </a:solidFill>
+                <a:latin typeface="Graphik TH" pitchFamily="34" charset="0"/>
+                <a:ea typeface="Graphik TH" pitchFamily="34" charset="-122"/>
+                <a:cs typeface="Graphik TH" pitchFamily="34" charset="-120"/>
+              </a:rPr>
+              <a:t>521.7K · 44.8%</a:t>
+            </a:r>
+            <a:endParaRPr lang="en-US" sz="1100" dirty="0"/>
+          </a:p>
+        </p:txBody>
+      </p:sp>
+      <p:sp>
+        <p:nvSpPr>
+          <p:cNvPr id="28" name="Text 26"/>
+          <p:cNvSpPr/>
+          <p:nvPr/>
+        </p:nvSpPr>
+        <p:spPr>
+          <a:xfrm>
+            <a:off x="749808" y="3913632"/>
+            <a:ext cx="1325880" cy="274320"/>
+          </a:xfrm>
+          <a:prstGeom prst="rect">
+            <a:avLst/>
+          </a:prstGeom>
+          <a:noFill/>
+          <a:ln/>
+        </p:spPr>
+        <p:txBody>
+          <a:bodyPr wrap="square" lIns="0" tIns="0" rIns="0" bIns="0" rtlCol="0" anchor="ctr"/>
+          <a:lstStyle/>
+          <a:p>
+            <a:pPr indent="0" marL="0">
+              <a:buNone/>
+            </a:pPr>
+            <a:r>
+              <a:rPr lang="en-US" sz="1100" b="1" dirty="0">
+                <a:solidFill>
+                  <a:srgbClr val="16233D"/>
+                </a:solidFill>
+                <a:latin typeface="Graphik TH" pitchFamily="34" charset="0"/>
+                <a:ea typeface="Graphik TH" pitchFamily="34" charset="-122"/>
+                <a:cs typeface="Graphik TH" pitchFamily="34" charset="-120"/>
+              </a:rPr>
+              <a:t>Inflow → N-1</a:t>
+            </a:r>
+            <a:endParaRPr lang="en-US" sz="1100" dirty="0"/>
+          </a:p>
+        </p:txBody>
+      </p:sp>
+      <p:sp>
+        <p:nvSpPr>
+          <p:cNvPr id="29" name="Shape 27"/>
+          <p:cNvSpPr/>
+          <p:nvPr/>
+        </p:nvSpPr>
+        <p:spPr>
+          <a:xfrm>
+            <a:off x="2185416" y="3968496"/>
+            <a:ext cx="652291" cy="173736"/>
+          </a:xfrm>
+          <a:prstGeom prst="roundRect">
+            <a:avLst>
+              <a:gd name="adj" fmla="val 21053"/>
+            </a:avLst>
+          </a:prstGeom>
+          <a:solidFill>
+            <a:srgbClr val="1E8E86"/>
+          </a:solidFill>
+          <a:ln/>
+        </p:spPr>
+      </p:sp>
+      <p:sp>
+        <p:nvSpPr>
+          <p:cNvPr id="30" name="Text 28"/>
+          <p:cNvSpPr/>
+          <p:nvPr/>
+        </p:nvSpPr>
+        <p:spPr>
+          <a:xfrm>
+            <a:off x="3127248" y="3913632"/>
+            <a:ext cx="1417320" cy="274320"/>
+          </a:xfrm>
+          <a:prstGeom prst="rect">
+            <a:avLst/>
+          </a:prstGeom>
+          <a:noFill/>
+          <a:ln/>
+        </p:spPr>
+        <p:txBody>
+          <a:bodyPr wrap="square" lIns="0" tIns="0" rIns="0" bIns="0" rtlCol="0" anchor="ctr"/>
+          <a:lstStyle/>
+          <a:p>
+            <a:pPr algn="r" indent="0" marL="0">
+              <a:buNone/>
+            </a:pPr>
+            <a:r>
+              <a:rPr lang="en-US" sz="1100" b="1" dirty="0">
+                <a:solidFill>
+                  <a:srgbClr val="16233D"/>
+                </a:solidFill>
+                <a:latin typeface="Graphik TH" pitchFamily="34" charset="0"/>
+                <a:ea typeface="Graphik TH" pitchFamily="34" charset="-122"/>
+                <a:cs typeface="Graphik TH" pitchFamily="34" charset="-120"/>
+              </a:rPr>
+              <a:t>408.9K · 35.1%</a:t>
+            </a:r>
+            <a:endParaRPr lang="en-US" sz="1100" dirty="0"/>
+          </a:p>
+        </p:txBody>
+      </p:sp>
+      <p:sp>
+        <p:nvSpPr>
+          <p:cNvPr id="31" name="Text 29"/>
+          <p:cNvSpPr/>
+          <p:nvPr/>
+        </p:nvSpPr>
+        <p:spPr>
+          <a:xfrm>
+            <a:off x="749808" y="4315968"/>
+            <a:ext cx="1325880" cy="274320"/>
+          </a:xfrm>
+          <a:prstGeom prst="rect">
+            <a:avLst/>
+          </a:prstGeom>
+          <a:noFill/>
+          <a:ln/>
+        </p:spPr>
+        <p:txBody>
+          <a:bodyPr wrap="square" lIns="0" tIns="0" rIns="0" bIns="0" rtlCol="0" anchor="ctr"/>
+          <a:lstStyle/>
+          <a:p>
+            <a:pPr indent="0" marL="0">
+              <a:buNone/>
+            </a:pPr>
+            <a:r>
+              <a:rPr lang="en-US" sz="1100" b="1" dirty="0">
+                <a:solidFill>
+                  <a:srgbClr val="16233D"/>
+                </a:solidFill>
+                <a:latin typeface="Graphik TH" pitchFamily="34" charset="0"/>
+                <a:ea typeface="Graphik TH" pitchFamily="34" charset="-122"/>
+                <a:cs typeface="Graphik TH" pitchFamily="34" charset="-120"/>
+              </a:rPr>
+              <a:t>Existing → N</a:t>
+            </a:r>
+            <a:endParaRPr lang="en-US" sz="1100" dirty="0"/>
+          </a:p>
+        </p:txBody>
+      </p:sp>
+      <p:sp>
+        <p:nvSpPr>
+          <p:cNvPr id="32" name="Shape 30"/>
+          <p:cNvSpPr/>
+          <p:nvPr/>
+        </p:nvSpPr>
+        <p:spPr>
+          <a:xfrm>
+            <a:off x="2185416" y="4370832"/>
+            <a:ext cx="297935" cy="173736"/>
+          </a:xfrm>
+          <a:prstGeom prst="roundRect">
+            <a:avLst>
+              <a:gd name="adj" fmla="val 21053"/>
+            </a:avLst>
+          </a:prstGeom>
+          <a:solidFill>
+            <a:srgbClr val="3FB89F"/>
+          </a:solidFill>
+          <a:ln/>
+        </p:spPr>
+      </p:sp>
+      <p:sp>
+        <p:nvSpPr>
+          <p:cNvPr id="33" name="Text 31"/>
+          <p:cNvSpPr/>
+          <p:nvPr/>
+        </p:nvSpPr>
+        <p:spPr>
+          <a:xfrm>
+            <a:off x="3127248" y="4315968"/>
+            <a:ext cx="1417320" cy="274320"/>
+          </a:xfrm>
+          <a:prstGeom prst="rect">
+            <a:avLst/>
+          </a:prstGeom>
+          <a:noFill/>
+          <a:ln/>
+        </p:spPr>
+        <p:txBody>
+          <a:bodyPr wrap="square" lIns="0" tIns="0" rIns="0" bIns="0" rtlCol="0" anchor="ctr"/>
+          <a:lstStyle/>
+          <a:p>
+            <a:pPr algn="r" indent="0" marL="0">
+              <a:buNone/>
+            </a:pPr>
+            <a:r>
+              <a:rPr lang="en-US" sz="1100" b="1" dirty="0">
+                <a:solidFill>
+                  <a:srgbClr val="16233D"/>
+                </a:solidFill>
+                <a:latin typeface="Graphik TH" pitchFamily="34" charset="0"/>
+                <a:ea typeface="Graphik TH" pitchFamily="34" charset="-122"/>
+                <a:cs typeface="Graphik TH" pitchFamily="34" charset="-120"/>
+              </a:rPr>
+              <a:t>186.8K · 16.0%</a:t>
+            </a:r>
+            <a:endParaRPr lang="en-US" sz="1100" dirty="0"/>
+          </a:p>
+        </p:txBody>
+      </p:sp>
+      <p:sp>
+        <p:nvSpPr>
+          <p:cNvPr id="34" name="Text 32"/>
+          <p:cNvSpPr/>
+          <p:nvPr/>
+        </p:nvSpPr>
+        <p:spPr>
+          <a:xfrm>
+            <a:off x="749808" y="4718304"/>
+            <a:ext cx="1325880" cy="274320"/>
+          </a:xfrm>
+          <a:prstGeom prst="rect">
+            <a:avLst/>
+          </a:prstGeom>
+          <a:noFill/>
+          <a:ln/>
+        </p:spPr>
+        <p:txBody>
+          <a:bodyPr wrap="square" lIns="0" tIns="0" rIns="0" bIns="0" rtlCol="0" anchor="ctr"/>
+          <a:lstStyle/>
+          <a:p>
+            <a:pPr indent="0" marL="0">
+              <a:buNone/>
+            </a:pPr>
+            <a:r>
+              <a:rPr lang="en-US" sz="1100" b="1" dirty="0">
+                <a:solidFill>
+                  <a:srgbClr val="16233D"/>
+                </a:solidFill>
+                <a:latin typeface="Graphik TH" pitchFamily="34" charset="0"/>
+                <a:ea typeface="Graphik TH" pitchFamily="34" charset="-122"/>
+                <a:cs typeface="Graphik TH" pitchFamily="34" charset="-120"/>
+              </a:rPr>
+              <a:t>Existing → N-1</a:t>
+            </a:r>
+            <a:endParaRPr lang="en-US" sz="1100" dirty="0"/>
+          </a:p>
+        </p:txBody>
+      </p:sp>
+      <p:sp>
+        <p:nvSpPr>
+          <p:cNvPr id="35" name="Shape 33"/>
+          <p:cNvSpPr/>
+          <p:nvPr/>
+        </p:nvSpPr>
+        <p:spPr>
+          <a:xfrm>
+            <a:off x="2185416" y="4773168"/>
+            <a:ext cx="74782" cy="173736"/>
+          </a:xfrm>
+          <a:prstGeom prst="roundRect">
+            <a:avLst>
+              <a:gd name="adj" fmla="val 48910"/>
+            </a:avLst>
+          </a:prstGeom>
+          <a:solidFill>
+            <a:srgbClr val="8DA0B8"/>
+          </a:solidFill>
+          <a:ln/>
+        </p:spPr>
+      </p:sp>
+      <p:sp>
+        <p:nvSpPr>
+          <p:cNvPr id="36" name="Text 34"/>
+          <p:cNvSpPr/>
+          <p:nvPr/>
+        </p:nvSpPr>
+        <p:spPr>
+          <a:xfrm>
+            <a:off x="3127248" y="4718304"/>
+            <a:ext cx="1417320" cy="274320"/>
+          </a:xfrm>
+          <a:prstGeom prst="rect">
+            <a:avLst/>
+          </a:prstGeom>
+          <a:noFill/>
+          <a:ln/>
+        </p:spPr>
+        <p:txBody>
+          <a:bodyPr wrap="square" lIns="0" tIns="0" rIns="0" bIns="0" rtlCol="0" anchor="ctr"/>
+          <a:lstStyle/>
+          <a:p>
+            <a:pPr algn="r" indent="0" marL="0">
+              <a:buNone/>
+            </a:pPr>
+            <a:r>
+              <a:rPr lang="en-US" sz="1100" b="1" dirty="0">
+                <a:solidFill>
+                  <a:srgbClr val="16233D"/>
+                </a:solidFill>
+                <a:latin typeface="Graphik TH" pitchFamily="34" charset="0"/>
+                <a:ea typeface="Graphik TH" pitchFamily="34" charset="-122"/>
+                <a:cs typeface="Graphik TH" pitchFamily="34" charset="-120"/>
+              </a:rPr>
+              <a:t>46.9K · 4.0%</a:t>
+            </a:r>
+            <a:endParaRPr lang="en-US" sz="1100" dirty="0"/>
+          </a:p>
+        </p:txBody>
+      </p:sp>
+      <p:sp>
+        <p:nvSpPr>
+          <p:cNvPr id="37" name="Text 35"/>
+          <p:cNvSpPr/>
+          <p:nvPr/>
+        </p:nvSpPr>
+        <p:spPr>
+          <a:xfrm>
+            <a:off x="749808" y="5120640"/>
+            <a:ext cx="3794760" cy="310896"/>
+          </a:xfrm>
+          <a:prstGeom prst="rect">
+            <a:avLst/>
+          </a:prstGeom>
+          <a:noFill/>
+          <a:ln/>
+        </p:spPr>
+        <p:txBody>
+          <a:bodyPr wrap="square" lIns="0" tIns="0" rIns="0" bIns="0" rtlCol="0" anchor="ctr"/>
+          <a:lstStyle/>
+          <a:p>
+            <a:pPr indent="0" marL="0">
+              <a:buNone/>
+            </a:pPr>
+            <a:r>
+              <a:rPr lang="en-US" sz="900" i="1" dirty="0">
+                <a:solidFill>
+                  <a:srgbClr val="6B7A90"/>
+                </a:solidFill>
+                <a:latin typeface="Graphik TH" pitchFamily="34" charset="0"/>
+                <a:ea typeface="Graphik TH" pitchFamily="34" charset="-122"/>
+                <a:cs typeface="Graphik TH" pitchFamily="34" charset="-120"/>
+              </a:rPr>
+              <a:t>Inflow applies the observed 4.68% acquisition rate to the 19.87M non-flagship base; replacement applies the observed upgrade rates to today's 1.55M flagship holders.</a:t>
+            </a:r>
+            <a:endParaRPr lang="en-US" sz="900" dirty="0"/>
+          </a:p>
+        </p:txBody>
+      </p:sp>
+      <p:sp>
+        <p:nvSpPr>
+          <p:cNvPr id="38" name="Shape 36"/>
+          <p:cNvSpPr/>
+          <p:nvPr/>
+        </p:nvSpPr>
+        <p:spPr>
+          <a:xfrm>
+            <a:off x="4992624" y="2761488"/>
+            <a:ext cx="3291840" cy="2743200"/>
+          </a:xfrm>
+          <a:prstGeom prst="roundRect">
+            <a:avLst>
+              <a:gd name="adj" fmla="val 3000"/>
+            </a:avLst>
+          </a:prstGeom>
+          <a:solidFill>
+            <a:srgbClr val="F1F4F9"/>
+          </a:solidFill>
+          <a:ln/>
+        </p:spPr>
+      </p:sp>
+      <p:sp>
+        <p:nvSpPr>
+          <p:cNvPr id="39" name="Text 37"/>
+          <p:cNvSpPr/>
+          <p:nvPr/>
+        </p:nvSpPr>
+        <p:spPr>
+          <a:xfrm>
+            <a:off x="5212080" y="2907792"/>
+            <a:ext cx="2852928" cy="256032"/>
+          </a:xfrm>
+          <a:prstGeom prst="rect">
+            <a:avLst/>
+          </a:prstGeom>
+          <a:noFill/>
+          <a:ln/>
+        </p:spPr>
+        <p:txBody>
+          <a:bodyPr wrap="square" lIns="0" tIns="0" rIns="0" bIns="0" rtlCol="0" anchor="ctr"/>
+          <a:lstStyle/>
+          <a:p>
+            <a:pPr indent="0" marL="0">
+              <a:buNone/>
+            </a:pPr>
+            <a:r>
+              <a:rPr lang="en-US" sz="1300" b="1" dirty="0">
+                <a:solidFill>
+                  <a:srgbClr val="16233D"/>
+                </a:solidFill>
+                <a:latin typeface="Cambria" pitchFamily="34" charset="0"/>
+                <a:ea typeface="Cambria" pitchFamily="34" charset="-122"/>
+                <a:cs typeface="Cambria" pitchFamily="34" charset="-120"/>
+              </a:rPr>
+              <a:t>Estimated buyers by risk band</a:t>
+            </a:r>
+            <a:endParaRPr lang="en-US" sz="1300" dirty="0"/>
+          </a:p>
+        </p:txBody>
+      </p:sp>
+      <p:sp>
+        <p:nvSpPr>
+          <p:cNvPr id="40" name="Text 38"/>
+          <p:cNvSpPr/>
+          <p:nvPr/>
+        </p:nvSpPr>
+        <p:spPr>
+          <a:xfrm>
+            <a:off x="5212080" y="3163824"/>
+            <a:ext cx="2852928" cy="219456"/>
+          </a:xfrm>
+          <a:prstGeom prst="rect">
+            <a:avLst/>
+          </a:prstGeom>
+          <a:noFill/>
+          <a:ln/>
+        </p:spPr>
+        <p:txBody>
+          <a:bodyPr wrap="square" lIns="0" tIns="0" rIns="0" bIns="0" rtlCol="0" anchor="ctr"/>
+          <a:lstStyle/>
+          <a:p>
+            <a:pPr indent="0" marL="0">
+              <a:buNone/>
+            </a:pPr>
+            <a:r>
+              <a:rPr lang="en-US" sz="950" dirty="0">
+                <a:solidFill>
+                  <a:srgbClr val="6B7A90"/>
+                </a:solidFill>
+                <a:latin typeface="Graphik TH" pitchFamily="34" charset="0"/>
+                <a:ea typeface="Graphik TH" pitchFamily="34" charset="-122"/>
+                <a:cs typeface="Graphik TH" pitchFamily="34" charset="-120"/>
+              </a:rPr>
+              <a:t>Using band-specific acquisition rates</a:t>
+            </a:r>
+            <a:endParaRPr lang="en-US" sz="950" dirty="0"/>
+          </a:p>
+        </p:txBody>
+      </p:sp>
+      <p:sp>
+        <p:nvSpPr>
+          <p:cNvPr id="41" name="Text 39"/>
+          <p:cNvSpPr/>
+          <p:nvPr/>
+        </p:nvSpPr>
+        <p:spPr>
+          <a:xfrm>
+            <a:off x="5212080" y="3511296"/>
+            <a:ext cx="868680" cy="274320"/>
+          </a:xfrm>
+          <a:prstGeom prst="rect">
+            <a:avLst/>
+          </a:prstGeom>
+          <a:noFill/>
+          <a:ln/>
+        </p:spPr>
+        <p:txBody>
+          <a:bodyPr wrap="square" lIns="0" tIns="0" rIns="0" bIns="0" rtlCol="0" anchor="ctr"/>
+          <a:lstStyle/>
+          <a:p>
+            <a:pPr indent="0" marL="0">
+              <a:buNone/>
+            </a:pPr>
+            <a:r>
+              <a:rPr lang="en-US" sz="1100" b="1" dirty="0">
+                <a:solidFill>
+                  <a:srgbClr val="16233D"/>
+                </a:solidFill>
+                <a:latin typeface="Graphik TH" pitchFamily="34" charset="0"/>
+                <a:ea typeface="Graphik TH" pitchFamily="34" charset="-122"/>
+                <a:cs typeface="Graphik TH" pitchFamily="34" charset="-120"/>
+              </a:rPr>
+              <a:t>Low</a:t>
+            </a:r>
+            <a:endParaRPr lang="en-US" sz="1100" dirty="0"/>
+          </a:p>
+        </p:txBody>
+      </p:sp>
+      <p:sp>
+        <p:nvSpPr>
+          <p:cNvPr id="42" name="Shape 40"/>
+          <p:cNvSpPr/>
+          <p:nvPr/>
+        </p:nvSpPr>
+        <p:spPr>
+          <a:xfrm>
+            <a:off x="6190488" y="3566160"/>
+            <a:ext cx="896112" cy="173736"/>
+          </a:xfrm>
+          <a:prstGeom prst="roundRect">
+            <a:avLst>
+              <a:gd name="adj" fmla="val 21053"/>
+            </a:avLst>
+          </a:prstGeom>
+          <a:solidFill>
+            <a:srgbClr val="3FB89F"/>
+          </a:solidFill>
+          <a:ln/>
+        </p:spPr>
+      </p:sp>
+      <p:sp>
+        <p:nvSpPr>
+          <p:cNvPr id="43" name="Text 41"/>
+          <p:cNvSpPr/>
+          <p:nvPr/>
+        </p:nvSpPr>
+        <p:spPr>
+          <a:xfrm>
+            <a:off x="7196328" y="3511296"/>
+            <a:ext cx="868680" cy="274320"/>
+          </a:xfrm>
+          <a:prstGeom prst="rect">
+            <a:avLst/>
+          </a:prstGeom>
+          <a:noFill/>
+          <a:ln/>
+        </p:spPr>
+        <p:txBody>
+          <a:bodyPr wrap="square" lIns="0" tIns="0" rIns="0" bIns="0" rtlCol="0" anchor="ctr"/>
+          <a:lstStyle/>
+          <a:p>
+            <a:pPr algn="r" indent="0" marL="0">
+              <a:buNone/>
+            </a:pPr>
+            <a:r>
+              <a:rPr lang="en-US" sz="1100" b="1" dirty="0">
+                <a:solidFill>
+                  <a:srgbClr val="16233D"/>
+                </a:solidFill>
+                <a:latin typeface="Graphik TH" pitchFamily="34" charset="0"/>
+                <a:ea typeface="Graphik TH" pitchFamily="34" charset="-122"/>
+                <a:cs typeface="Graphik TH" pitchFamily="34" charset="-120"/>
+              </a:rPr>
+              <a:t>635.8K</a:t>
+            </a:r>
+            <a:endParaRPr lang="en-US" sz="1100" dirty="0"/>
+          </a:p>
+        </p:txBody>
+      </p:sp>
+      <p:sp>
+        <p:nvSpPr>
+          <p:cNvPr id="44" name="Text 42"/>
+          <p:cNvSpPr/>
+          <p:nvPr/>
+        </p:nvSpPr>
+        <p:spPr>
+          <a:xfrm>
+            <a:off x="5212080" y="3913632"/>
+            <a:ext cx="868680" cy="274320"/>
+          </a:xfrm>
+          <a:prstGeom prst="rect">
+            <a:avLst/>
+          </a:prstGeom>
+          <a:noFill/>
+          <a:ln/>
+        </p:spPr>
+        <p:txBody>
+          <a:bodyPr wrap="square" lIns="0" tIns="0" rIns="0" bIns="0" rtlCol="0" anchor="ctr"/>
+          <a:lstStyle/>
+          <a:p>
+            <a:pPr indent="0" marL="0">
+              <a:buNone/>
+            </a:pPr>
+            <a:r>
+              <a:rPr lang="en-US" sz="1100" b="1" dirty="0">
+                <a:solidFill>
+                  <a:srgbClr val="16233D"/>
+                </a:solidFill>
+                <a:latin typeface="Graphik TH" pitchFamily="34" charset="0"/>
+                <a:ea typeface="Graphik TH" pitchFamily="34" charset="-122"/>
+                <a:cs typeface="Graphik TH" pitchFamily="34" charset="-120"/>
+              </a:rPr>
+              <a:t>High</a:t>
+            </a:r>
+            <a:endParaRPr lang="en-US" sz="1100" dirty="0"/>
+          </a:p>
+        </p:txBody>
+      </p:sp>
+      <p:sp>
+        <p:nvSpPr>
+          <p:cNvPr id="45" name="Shape 43"/>
+          <p:cNvSpPr/>
+          <p:nvPr/>
+        </p:nvSpPr>
+        <p:spPr>
+          <a:xfrm>
+            <a:off x="6190488" y="3968496"/>
+            <a:ext cx="375062" cy="173736"/>
+          </a:xfrm>
+          <a:prstGeom prst="roundRect">
+            <a:avLst>
+              <a:gd name="adj" fmla="val 21053"/>
+            </a:avLst>
+          </a:prstGeom>
+          <a:solidFill>
+            <a:srgbClr val="165A73"/>
+          </a:solidFill>
+          <a:ln/>
+        </p:spPr>
+      </p:sp>
+      <p:sp>
+        <p:nvSpPr>
+          <p:cNvPr id="46" name="Text 44"/>
+          <p:cNvSpPr/>
+          <p:nvPr/>
+        </p:nvSpPr>
+        <p:spPr>
+          <a:xfrm>
+            <a:off x="7196328" y="3913632"/>
+            <a:ext cx="868680" cy="274320"/>
+          </a:xfrm>
+          <a:prstGeom prst="rect">
+            <a:avLst/>
+          </a:prstGeom>
+          <a:noFill/>
+          <a:ln/>
+        </p:spPr>
+        <p:txBody>
+          <a:bodyPr wrap="square" lIns="0" tIns="0" rIns="0" bIns="0" rtlCol="0" anchor="ctr"/>
+          <a:lstStyle/>
+          <a:p>
+            <a:pPr algn="r" indent="0" marL="0">
+              <a:buNone/>
+            </a:pPr>
+            <a:r>
+              <a:rPr lang="en-US" sz="1100" b="1" dirty="0">
+                <a:solidFill>
+                  <a:srgbClr val="16233D"/>
+                </a:solidFill>
+                <a:latin typeface="Graphik TH" pitchFamily="34" charset="0"/>
+                <a:ea typeface="Graphik TH" pitchFamily="34" charset="-122"/>
+                <a:cs typeface="Graphik TH" pitchFamily="34" charset="-120"/>
+              </a:rPr>
+              <a:t>266.1K</a:t>
+            </a:r>
+            <a:endParaRPr lang="en-US" sz="1100" dirty="0"/>
+          </a:p>
+        </p:txBody>
+      </p:sp>
+      <p:sp>
+        <p:nvSpPr>
+          <p:cNvPr id="47" name="Text 45"/>
+          <p:cNvSpPr/>
+          <p:nvPr/>
+        </p:nvSpPr>
+        <p:spPr>
+          <a:xfrm>
+            <a:off x="5212080" y="4315968"/>
+            <a:ext cx="868680" cy="274320"/>
+          </a:xfrm>
+          <a:prstGeom prst="rect">
+            <a:avLst/>
+          </a:prstGeom>
+          <a:noFill/>
+          <a:ln/>
+        </p:spPr>
+        <p:txBody>
+          <a:bodyPr wrap="square" lIns="0" tIns="0" rIns="0" bIns="0" rtlCol="0" anchor="ctr"/>
+          <a:lstStyle/>
+          <a:p>
+            <a:pPr indent="0" marL="0">
+              <a:buNone/>
+            </a:pPr>
+            <a:r>
+              <a:rPr lang="en-US" sz="1100" b="1" dirty="0">
+                <a:solidFill>
+                  <a:srgbClr val="16233D"/>
+                </a:solidFill>
+                <a:latin typeface="Graphik TH" pitchFamily="34" charset="0"/>
+                <a:ea typeface="Graphik TH" pitchFamily="34" charset="-122"/>
+                <a:cs typeface="Graphik TH" pitchFamily="34" charset="-120"/>
+              </a:rPr>
+              <a:t>Mid</a:t>
+            </a:r>
+            <a:endParaRPr lang="en-US" sz="1100" dirty="0"/>
+          </a:p>
+        </p:txBody>
+      </p:sp>
+      <p:sp>
+        <p:nvSpPr>
+          <p:cNvPr id="48" name="Shape 46"/>
+          <p:cNvSpPr/>
+          <p:nvPr/>
+        </p:nvSpPr>
+        <p:spPr>
+          <a:xfrm>
+            <a:off x="6190488" y="4370832"/>
+            <a:ext cx="360310" cy="173736"/>
+          </a:xfrm>
+          <a:prstGeom prst="roundRect">
+            <a:avLst>
+              <a:gd name="adj" fmla="val 21053"/>
+            </a:avLst>
+          </a:prstGeom>
+          <a:solidFill>
+            <a:srgbClr val="1E8E86"/>
+          </a:solidFill>
+          <a:ln/>
+        </p:spPr>
+      </p:sp>
+      <p:sp>
+        <p:nvSpPr>
+          <p:cNvPr id="49" name="Text 47"/>
+          <p:cNvSpPr/>
+          <p:nvPr/>
+        </p:nvSpPr>
+        <p:spPr>
+          <a:xfrm>
+            <a:off x="7196328" y="4315968"/>
+            <a:ext cx="868680" cy="274320"/>
+          </a:xfrm>
+          <a:prstGeom prst="rect">
+            <a:avLst/>
+          </a:prstGeom>
+          <a:noFill/>
+          <a:ln/>
+        </p:spPr>
+        <p:txBody>
+          <a:bodyPr wrap="square" lIns="0" tIns="0" rIns="0" bIns="0" rtlCol="0" anchor="ctr"/>
+          <a:lstStyle/>
+          <a:p>
+            <a:pPr algn="r" indent="0" marL="0">
+              <a:buNone/>
+            </a:pPr>
+            <a:r>
+              <a:rPr lang="en-US" sz="1100" b="1" dirty="0">
+                <a:solidFill>
+                  <a:srgbClr val="16233D"/>
+                </a:solidFill>
+                <a:latin typeface="Graphik TH" pitchFamily="34" charset="0"/>
+                <a:ea typeface="Graphik TH" pitchFamily="34" charset="-122"/>
+                <a:cs typeface="Graphik TH" pitchFamily="34" charset="-120"/>
+              </a:rPr>
+              <a:t>255.6K</a:t>
+            </a:r>
+            <a:endParaRPr lang="en-US" sz="1100" dirty="0"/>
+          </a:p>
+        </p:txBody>
+      </p:sp>
+      <p:sp>
+        <p:nvSpPr>
+          <p:cNvPr id="50" name="Text 48"/>
+          <p:cNvSpPr/>
+          <p:nvPr/>
+        </p:nvSpPr>
+        <p:spPr>
+          <a:xfrm>
+            <a:off x="5212080" y="4718304"/>
+            <a:ext cx="868680" cy="274320"/>
+          </a:xfrm>
+          <a:prstGeom prst="rect">
+            <a:avLst/>
+          </a:prstGeom>
+          <a:noFill/>
+          <a:ln/>
+        </p:spPr>
+        <p:txBody>
+          <a:bodyPr wrap="square" lIns="0" tIns="0" rIns="0" bIns="0" rtlCol="0" anchor="ctr"/>
+          <a:lstStyle/>
+          <a:p>
+            <a:pPr indent="0" marL="0">
+              <a:buNone/>
+            </a:pPr>
+            <a:r>
+              <a:rPr lang="en-US" sz="1100" b="1" dirty="0">
+                <a:solidFill>
+                  <a:srgbClr val="16233D"/>
+                </a:solidFill>
+                <a:latin typeface="Graphik TH" pitchFamily="34" charset="0"/>
+                <a:ea typeface="Graphik TH" pitchFamily="34" charset="-122"/>
+                <a:cs typeface="Graphik TH" pitchFamily="34" charset="-120"/>
+              </a:rPr>
+              <a:t>Null</a:t>
+            </a:r>
+            <a:endParaRPr lang="en-US" sz="1100" dirty="0"/>
+          </a:p>
+        </p:txBody>
+      </p:sp>
+      <p:sp>
+        <p:nvSpPr>
+          <p:cNvPr id="51" name="Shape 49"/>
+          <p:cNvSpPr/>
+          <p:nvPr/>
+        </p:nvSpPr>
+        <p:spPr>
+          <a:xfrm>
+            <a:off x="6190488" y="4773168"/>
+            <a:ext cx="45720" cy="173736"/>
+          </a:xfrm>
+          <a:prstGeom prst="roundRect">
+            <a:avLst>
+              <a:gd name="adj" fmla="val 80000"/>
+            </a:avLst>
+          </a:prstGeom>
+          <a:solidFill>
+            <a:srgbClr val="8DA0B8"/>
+          </a:solidFill>
+          <a:ln/>
+        </p:spPr>
+      </p:sp>
+      <p:sp>
+        <p:nvSpPr>
+          <p:cNvPr id="52" name="Text 50"/>
+          <p:cNvSpPr/>
+          <p:nvPr/>
+        </p:nvSpPr>
+        <p:spPr>
+          <a:xfrm>
+            <a:off x="7196328" y="4718304"/>
+            <a:ext cx="868680" cy="274320"/>
+          </a:xfrm>
+          <a:prstGeom prst="rect">
+            <a:avLst/>
+          </a:prstGeom>
+          <a:noFill/>
+          <a:ln/>
+        </p:spPr>
+        <p:txBody>
+          <a:bodyPr wrap="square" lIns="0" tIns="0" rIns="0" bIns="0" rtlCol="0" anchor="ctr"/>
+          <a:lstStyle/>
+          <a:p>
+            <a:pPr algn="r" indent="0" marL="0">
+              <a:buNone/>
+            </a:pPr>
+            <a:r>
+              <a:rPr lang="en-US" sz="1100" b="1" dirty="0">
+                <a:solidFill>
+                  <a:srgbClr val="16233D"/>
+                </a:solidFill>
+                <a:latin typeface="Graphik TH" pitchFamily="34" charset="0"/>
+                <a:ea typeface="Graphik TH" pitchFamily="34" charset="-122"/>
+                <a:cs typeface="Graphik TH" pitchFamily="34" charset="-120"/>
+              </a:rPr>
+              <a:t>6.6K</a:t>
+            </a:r>
+            <a:endParaRPr lang="en-US" sz="1100" dirty="0"/>
+          </a:p>
+        </p:txBody>
+      </p:sp>
+      <p:sp>
+        <p:nvSpPr>
+          <p:cNvPr id="53" name="Text 51"/>
+          <p:cNvSpPr/>
+          <p:nvPr/>
+        </p:nvSpPr>
+        <p:spPr>
+          <a:xfrm>
+            <a:off x="5212080" y="5120640"/>
+            <a:ext cx="2852928" cy="310896"/>
+          </a:xfrm>
+          <a:prstGeom prst="rect">
+            <a:avLst/>
+          </a:prstGeom>
+          <a:noFill/>
+          <a:ln/>
+        </p:spPr>
+        <p:txBody>
+          <a:bodyPr wrap="square" lIns="0" tIns="0" rIns="0" bIns="0" rtlCol="0" anchor="ctr"/>
+          <a:lstStyle/>
+          <a:p>
+            <a:pPr indent="0" marL="0">
+              <a:buNone/>
+            </a:pPr>
+            <a:r>
+              <a:rPr lang="en-US" sz="900" i="1" dirty="0">
+                <a:solidFill>
+                  <a:srgbClr val="6B7A90"/>
+                </a:solidFill>
+                <a:latin typeface="Graphik TH" pitchFamily="34" charset="0"/>
+                <a:ea typeface="Graphik TH" pitchFamily="34" charset="-122"/>
+                <a:cs typeface="Graphik TH" pitchFamily="34" charset="-120"/>
+              </a:rPr>
+              <a:t>Low and Mid risk together are 891.5K — 76.6% of expected buyers.</a:t>
+            </a:r>
+            <a:endParaRPr lang="en-US" sz="900" dirty="0"/>
+          </a:p>
+        </p:txBody>
+      </p:sp>
+      <p:sp>
+        <p:nvSpPr>
+          <p:cNvPr id="54" name="Shape 52"/>
+          <p:cNvSpPr/>
+          <p:nvPr/>
+        </p:nvSpPr>
+        <p:spPr>
+          <a:xfrm>
+            <a:off x="8513064" y="2761488"/>
+            <a:ext cx="3291840" cy="2743200"/>
+          </a:xfrm>
+          <a:prstGeom prst="roundRect">
+            <a:avLst>
+              <a:gd name="adj" fmla="val 3000"/>
+            </a:avLst>
+          </a:prstGeom>
+          <a:solidFill>
+            <a:srgbClr val="F1F4F9"/>
+          </a:solidFill>
+          <a:ln/>
+        </p:spPr>
+      </p:sp>
+      <p:sp>
+        <p:nvSpPr>
+          <p:cNvPr id="55" name="Text 53"/>
+          <p:cNvSpPr/>
+          <p:nvPr/>
+        </p:nvSpPr>
+        <p:spPr>
+          <a:xfrm>
+            <a:off x="8732520" y="2907792"/>
+            <a:ext cx="2852928" cy="256032"/>
+          </a:xfrm>
+          <a:prstGeom prst="rect">
+            <a:avLst/>
+          </a:prstGeom>
+          <a:noFill/>
+          <a:ln/>
+        </p:spPr>
+        <p:txBody>
+          <a:bodyPr wrap="square" lIns="0" tIns="0" rIns="0" bIns="0" rtlCol="0" anchor="ctr"/>
+          <a:lstStyle/>
+          <a:p>
+            <a:pPr indent="0" marL="0">
+              <a:buNone/>
+            </a:pPr>
+            <a:r>
+              <a:rPr lang="en-US" sz="1300" b="1" dirty="0">
+                <a:solidFill>
+                  <a:srgbClr val="16233D"/>
+                </a:solidFill>
+                <a:latin typeface="Cambria" pitchFamily="34" charset="0"/>
+                <a:ea typeface="Cambria" pitchFamily="34" charset="-122"/>
+                <a:cs typeface="Cambria" pitchFamily="34" charset="-120"/>
+              </a:rPr>
+              <a:t>Sensitivity</a:t>
+            </a:r>
+            <a:endParaRPr lang="en-US" sz="1300" dirty="0"/>
+          </a:p>
+        </p:txBody>
+      </p:sp>
+      <p:sp>
+        <p:nvSpPr>
+          <p:cNvPr id="56" name="Text 54"/>
+          <p:cNvSpPr/>
+          <p:nvPr/>
+        </p:nvSpPr>
+        <p:spPr>
+          <a:xfrm>
+            <a:off x="8732520" y="3163824"/>
+            <a:ext cx="2852928" cy="219456"/>
+          </a:xfrm>
+          <a:prstGeom prst="rect">
+            <a:avLst/>
+          </a:prstGeom>
+          <a:noFill/>
+          <a:ln/>
+        </p:spPr>
+        <p:txBody>
+          <a:bodyPr wrap="square" lIns="0" tIns="0" rIns="0" bIns="0" rtlCol="0" anchor="ctr"/>
+          <a:lstStyle/>
+          <a:p>
+            <a:pPr indent="0" marL="0">
+              <a:buNone/>
+            </a:pPr>
+            <a:r>
+              <a:rPr lang="en-US" sz="950" dirty="0">
+                <a:solidFill>
+                  <a:srgbClr val="6B7A90"/>
+                </a:solidFill>
+                <a:latin typeface="Graphik TH" pitchFamily="34" charset="0"/>
+                <a:ea typeface="Graphik TH" pitchFamily="34" charset="-122"/>
+                <a:cs typeface="Graphik TH" pitchFamily="34" charset="-120"/>
+              </a:rPr>
+              <a:t>Total buyers under three rate assumptions</a:t>
+            </a:r>
+            <a:endParaRPr lang="en-US" sz="950" dirty="0"/>
+          </a:p>
+        </p:txBody>
+      </p:sp>
+      <p:sp>
+        <p:nvSpPr>
+          <p:cNvPr id="57" name="Text 55"/>
+          <p:cNvSpPr/>
+          <p:nvPr/>
+        </p:nvSpPr>
+        <p:spPr>
+          <a:xfrm>
+            <a:off x="8732520" y="3511296"/>
+            <a:ext cx="1143000" cy="274320"/>
+          </a:xfrm>
+          <a:prstGeom prst="rect">
+            <a:avLst/>
+          </a:prstGeom>
+          <a:noFill/>
+          <a:ln/>
+        </p:spPr>
+        <p:txBody>
+          <a:bodyPr wrap="square" lIns="0" tIns="0" rIns="0" bIns="0" rtlCol="0" anchor="ctr"/>
+          <a:lstStyle/>
+          <a:p>
+            <a:pPr indent="0" marL="0">
+              <a:buNone/>
+            </a:pPr>
+            <a:r>
+              <a:rPr lang="en-US" sz="1100" b="1" dirty="0">
+                <a:solidFill>
+                  <a:srgbClr val="16233D"/>
+                </a:solidFill>
+                <a:latin typeface="Graphik TH" pitchFamily="34" charset="0"/>
+                <a:ea typeface="Graphik TH" pitchFamily="34" charset="-122"/>
+                <a:cs typeface="Graphik TH" pitchFamily="34" charset="-120"/>
+              </a:rPr>
+              <a:t>Optimistic</a:t>
+            </a:r>
+            <a:endParaRPr lang="en-US" sz="1100" dirty="0"/>
+          </a:p>
+        </p:txBody>
+      </p:sp>
+      <p:sp>
+        <p:nvSpPr>
+          <p:cNvPr id="58" name="Shape 56"/>
+          <p:cNvSpPr/>
+          <p:nvPr/>
+        </p:nvSpPr>
+        <p:spPr>
+          <a:xfrm>
+            <a:off x="9985248" y="3566160"/>
+            <a:ext cx="621792" cy="173736"/>
+          </a:xfrm>
+          <a:prstGeom prst="roundRect">
+            <a:avLst>
+              <a:gd name="adj" fmla="val 21053"/>
+            </a:avLst>
+          </a:prstGeom>
+          <a:solidFill>
+            <a:srgbClr val="165A73"/>
+          </a:solidFill>
+          <a:ln/>
+        </p:spPr>
+      </p:sp>
+      <p:sp>
+        <p:nvSpPr>
+          <p:cNvPr id="59" name="Text 57"/>
+          <p:cNvSpPr/>
+          <p:nvPr/>
+        </p:nvSpPr>
+        <p:spPr>
+          <a:xfrm>
+            <a:off x="10716768" y="3511296"/>
+            <a:ext cx="868680" cy="274320"/>
+          </a:xfrm>
+          <a:prstGeom prst="rect">
+            <a:avLst/>
+          </a:prstGeom>
+          <a:noFill/>
+          <a:ln/>
+        </p:spPr>
+        <p:txBody>
+          <a:bodyPr wrap="square" lIns="0" tIns="0" rIns="0" bIns="0" rtlCol="0" anchor="ctr"/>
+          <a:lstStyle/>
+          <a:p>
+            <a:pPr algn="r" indent="0" marL="0">
+              <a:buNone/>
+            </a:pPr>
+            <a:r>
+              <a:rPr lang="en-US" sz="1100" b="1" dirty="0">
+                <a:solidFill>
+                  <a:srgbClr val="16233D"/>
+                </a:solidFill>
+                <a:latin typeface="Graphik TH" pitchFamily="34" charset="0"/>
+                <a:ea typeface="Graphik TH" pitchFamily="34" charset="-122"/>
+                <a:cs typeface="Graphik TH" pitchFamily="34" charset="-120"/>
+              </a:rPr>
+              <a:t>1.30M</a:t>
+            </a:r>
+            <a:endParaRPr lang="en-US" sz="1100" dirty="0"/>
+          </a:p>
+        </p:txBody>
+      </p:sp>
+      <p:sp>
+        <p:nvSpPr>
+          <p:cNvPr id="60" name="Text 58"/>
+          <p:cNvSpPr/>
+          <p:nvPr/>
+        </p:nvSpPr>
+        <p:spPr>
+          <a:xfrm>
+            <a:off x="8732520" y="3913632"/>
+            <a:ext cx="1143000" cy="274320"/>
+          </a:xfrm>
+          <a:prstGeom prst="rect">
+            <a:avLst/>
+          </a:prstGeom>
+          <a:noFill/>
+          <a:ln/>
+        </p:spPr>
+        <p:txBody>
+          <a:bodyPr wrap="square" lIns="0" tIns="0" rIns="0" bIns="0" rtlCol="0" anchor="ctr"/>
+          <a:lstStyle/>
+          <a:p>
+            <a:pPr indent="0" marL="0">
+              <a:buNone/>
+            </a:pPr>
+            <a:r>
+              <a:rPr lang="en-US" sz="1100" b="1" dirty="0">
+                <a:solidFill>
+                  <a:srgbClr val="16233D"/>
+                </a:solidFill>
+                <a:latin typeface="Graphik TH" pitchFamily="34" charset="0"/>
+                <a:ea typeface="Graphik TH" pitchFamily="34" charset="-122"/>
+                <a:cs typeface="Graphik TH" pitchFamily="34" charset="-120"/>
+              </a:rPr>
+              <a:t>Base</a:t>
+            </a:r>
+            <a:endParaRPr lang="en-US" sz="1100" dirty="0"/>
+          </a:p>
+        </p:txBody>
+      </p:sp>
+      <p:sp>
+        <p:nvSpPr>
+          <p:cNvPr id="61" name="Shape 59"/>
+          <p:cNvSpPr/>
+          <p:nvPr/>
+        </p:nvSpPr>
+        <p:spPr>
+          <a:xfrm>
+            <a:off x="9985248" y="3968496"/>
+            <a:ext cx="558683" cy="173736"/>
+          </a:xfrm>
+          <a:prstGeom prst="roundRect">
+            <a:avLst>
+              <a:gd name="adj" fmla="val 21053"/>
+            </a:avLst>
+          </a:prstGeom>
+          <a:solidFill>
+            <a:srgbClr val="1E8E86"/>
+          </a:solidFill>
+          <a:ln/>
+        </p:spPr>
+      </p:sp>
+      <p:sp>
+        <p:nvSpPr>
+          <p:cNvPr id="62" name="Text 60"/>
+          <p:cNvSpPr/>
+          <p:nvPr/>
+        </p:nvSpPr>
+        <p:spPr>
+          <a:xfrm>
+            <a:off x="10716768" y="3913632"/>
+            <a:ext cx="868680" cy="274320"/>
+          </a:xfrm>
+          <a:prstGeom prst="rect">
+            <a:avLst/>
+          </a:prstGeom>
+          <a:noFill/>
+          <a:ln/>
+        </p:spPr>
+        <p:txBody>
+          <a:bodyPr wrap="square" lIns="0" tIns="0" rIns="0" bIns="0" rtlCol="0" anchor="ctr"/>
+          <a:lstStyle/>
+          <a:p>
+            <a:pPr algn="r" indent="0" marL="0">
+              <a:buNone/>
+            </a:pPr>
+            <a:r>
+              <a:rPr lang="en-US" sz="1100" b="1" dirty="0">
+                <a:solidFill>
+                  <a:srgbClr val="16233D"/>
+                </a:solidFill>
+                <a:latin typeface="Graphik TH" pitchFamily="34" charset="0"/>
+                <a:ea typeface="Graphik TH" pitchFamily="34" charset="-122"/>
+                <a:cs typeface="Graphik TH" pitchFamily="34" charset="-120"/>
+              </a:rPr>
+              <a:t>1.16M</a:t>
+            </a:r>
+            <a:endParaRPr lang="en-US" sz="1100" dirty="0"/>
+          </a:p>
+        </p:txBody>
+      </p:sp>
+      <p:sp>
+        <p:nvSpPr>
+          <p:cNvPr id="63" name="Text 61"/>
+          <p:cNvSpPr/>
+          <p:nvPr/>
+        </p:nvSpPr>
+        <p:spPr>
+          <a:xfrm>
+            <a:off x="8732520" y="4315968"/>
+            <a:ext cx="1143000" cy="274320"/>
+          </a:xfrm>
+          <a:prstGeom prst="rect">
+            <a:avLst/>
+          </a:prstGeom>
+          <a:noFill/>
+          <a:ln/>
+        </p:spPr>
+        <p:txBody>
+          <a:bodyPr wrap="square" lIns="0" tIns="0" rIns="0" bIns="0" rtlCol="0" anchor="ctr"/>
+          <a:lstStyle/>
+          <a:p>
+            <a:pPr indent="0" marL="0">
+              <a:buNone/>
+            </a:pPr>
+            <a:r>
+              <a:rPr lang="en-US" sz="1100" b="1" dirty="0">
+                <a:solidFill>
+                  <a:srgbClr val="16233D"/>
+                </a:solidFill>
+                <a:latin typeface="Graphik TH" pitchFamily="34" charset="0"/>
+                <a:ea typeface="Graphik TH" pitchFamily="34" charset="-122"/>
+                <a:cs typeface="Graphik TH" pitchFamily="34" charset="-120"/>
+              </a:rPr>
+              <a:t>Conservative</a:t>
+            </a:r>
+            <a:endParaRPr lang="en-US" sz="1100" dirty="0"/>
+          </a:p>
+        </p:txBody>
+      </p:sp>
+      <p:sp>
+        <p:nvSpPr>
+          <p:cNvPr id="64" name="Shape 62"/>
+          <p:cNvSpPr/>
+          <p:nvPr/>
+        </p:nvSpPr>
+        <p:spPr>
+          <a:xfrm>
+            <a:off x="9985248" y="4370832"/>
+            <a:ext cx="496798" cy="173736"/>
+          </a:xfrm>
+          <a:prstGeom prst="roundRect">
+            <a:avLst>
+              <a:gd name="adj" fmla="val 21053"/>
+            </a:avLst>
+          </a:prstGeom>
+          <a:solidFill>
+            <a:srgbClr val="3FB89F"/>
+          </a:solidFill>
+          <a:ln/>
+        </p:spPr>
+      </p:sp>
+      <p:sp>
+        <p:nvSpPr>
+          <p:cNvPr id="65" name="Text 63"/>
+          <p:cNvSpPr/>
+          <p:nvPr/>
+        </p:nvSpPr>
+        <p:spPr>
+          <a:xfrm>
+            <a:off x="10716768" y="4315968"/>
+            <a:ext cx="868680" cy="274320"/>
+          </a:xfrm>
+          <a:prstGeom prst="rect">
+            <a:avLst/>
+          </a:prstGeom>
+          <a:noFill/>
+          <a:ln/>
+        </p:spPr>
+        <p:txBody>
+          <a:bodyPr wrap="square" lIns="0" tIns="0" rIns="0" bIns="0" rtlCol="0" anchor="ctr"/>
+          <a:lstStyle/>
+          <a:p>
+            <a:pPr algn="r" indent="0" marL="0">
+              <a:buNone/>
+            </a:pPr>
+            <a:r>
+              <a:rPr lang="en-US" sz="1100" b="1" dirty="0">
+                <a:solidFill>
+                  <a:srgbClr val="16233D"/>
+                </a:solidFill>
+                <a:latin typeface="Graphik TH" pitchFamily="34" charset="0"/>
+                <a:ea typeface="Graphik TH" pitchFamily="34" charset="-122"/>
+                <a:cs typeface="Graphik TH" pitchFamily="34" charset="-120"/>
+              </a:rPr>
+              <a:t>1.04M</a:t>
+            </a:r>
+            <a:endParaRPr lang="en-US" sz="1100" dirty="0"/>
+          </a:p>
+        </p:txBody>
+      </p:sp>
+      <p:sp>
+        <p:nvSpPr>
+          <p:cNvPr id="66" name="Text 64"/>
+          <p:cNvSpPr/>
+          <p:nvPr/>
+        </p:nvSpPr>
+        <p:spPr>
+          <a:xfrm>
+            <a:off x="8732520" y="5120640"/>
+            <a:ext cx="2852928" cy="310896"/>
+          </a:xfrm>
+          <a:prstGeom prst="rect">
+            <a:avLst/>
+          </a:prstGeom>
+          <a:noFill/>
+          <a:ln/>
+        </p:spPr>
+        <p:txBody>
+          <a:bodyPr wrap="square" lIns="0" tIns="0" rIns="0" bIns="0" rtlCol="0" anchor="ctr"/>
+          <a:lstStyle/>
+          <a:p>
+            <a:pPr indent="0" marL="0">
+              <a:buNone/>
+            </a:pPr>
+            <a:r>
+              <a:rPr lang="en-US" sz="900" i="1" dirty="0">
+                <a:solidFill>
+                  <a:srgbClr val="6B7A90"/>
+                </a:solidFill>
+                <a:latin typeface="Graphik TH" pitchFamily="34" charset="0"/>
+                <a:ea typeface="Graphik TH" pitchFamily="34" charset="-122"/>
+                <a:cs typeface="Graphik TH" pitchFamily="34" charset="-120"/>
+              </a:rPr>
+              <a:t>Conservative: 13% upgrade of the flagship base, 4.2% inflow. Optimistic: 17% and 5.2%.</a:t>
+            </a:r>
+            <a:endParaRPr lang="en-US" sz="900" dirty="0"/>
+          </a:p>
+        </p:txBody>
+      </p:sp>
+    </p:spTree>
+  </p:cSld>
+  <p:clrMapOvr>
+    <a:masterClrMapping/>
+  </p:clrMapOvr>
+</p:sld>
+</file>
+
 <file path=ppt/theme/theme1.xml><?xml version="1.0" encoding="utf-8"?>
 <a:theme xmlns:a="http://schemas.openxmlformats.org/drawingml/2006/main" name="Office Theme">
   <a:themeElements>

</xml_diff>